<commit_message>
Event queue: students build one (a sound queue in Zelda's exercise); Angry Birds shows one kept by a library
- Zelda: the event queue answers the re-entrancy pitfall, links to Snake's input buffer, and
  the sound exercise turns SoundManager into a queue
- Angry Birds: Box2D keeps the queue, and the facade drains it after each step

Co-Authored-By: Claude Opus 5.5 <noreply@anthropic.com>
Claude-Session: https://claude.ai/code/session_012sjsUQBbC7zon57rWHoo9d
</commit_message>
<xml_diff>
--- a/slides/07 The Legend of Zelda.pptx
+++ b/slides/07 The Legend of Zelda.pptx
@@ -2277,6 +2277,11 @@
           <a:p>
             <a:r>
               <a:t>The OnPlayerDied chain is the one to trace first: room, dungeon, play state.</a:t>
+            </a:r>
+          </a:p>
+          <a:p>
+            <a:r>
+              <a:t>The sound queue: a HashSet of names that PlaySound adds to (duplicates merge for free), played and cleared once per frame after the update. A sound can be up to a frame late; nobody hears it.</a:t>
             </a:r>
           </a:p>
           <a:p>
@@ -15885,7 +15890,7 @@
             </a:pPr>
             <a:r>
               <a:rPr lang="en"/>
-              <a:t>SoundManager.PlaySound is called from many classes. How would events help?</a:t>
+              <a:t>SoundManager.PlaySound is called from many classes. How would events help? Then queue the sounds, and play each once per frame</a:t>
             </a:r>
             <a:endParaRPr/>
           </a:p>

</xml_diff>

<commit_message>
Zelda page and deck follow the Tiny Dungeon art
Co-Authored-By: Claude Opus 5.5 <noreply@anthropic.com>
Claude-Session: https://claude.ai/code/session_012sjsUQBbC7zon57rWHoo9d
</commit_message>
<xml_diff>
--- a/slides/07 The Legend of Zelda.pptx
+++ b/slides/07 The Legend of Zelda.pptx
@@ -2919,7 +2919,7 @@
           <a:lstStyle/>
           <a:p>
             <a:r>
-              <a:t>A new enemy is one XML block and a row in the sheet. Ask the question: someone writes type="skelton". When do you find out? Only at runtime. That’s the cost.</a:t>
+              <a:t>A new enemy is one XML block and a row in the sheet. Ask the question: someone writes type="rta". When do you find out? Only at runtime. That’s the cost.</a:t>
             </a:r>
           </a:p>
         </p:txBody>
@@ -7977,15 +7977,15 @@
           <p:nvPr/>
         </p:nvPicPr>
         <p:blipFill>
-          <a:blip r:embed="rId4"/>
+          <a:blip r:embed="rId3"/>
           <a:stretch>
             <a:fillRect/>
           </a:stretch>
         </p:blipFill>
         <p:spPr>
           <a:xfrm>
-            <a:off x="1597488" y="920715"/>
-            <a:ext cx="5949024" cy="4070384"/>
+            <a:off x="1597489" y="920715"/>
+            <a:ext cx="5949022" cy="4070384"/>
           </a:xfrm>
           <a:prstGeom prst="rect">
             <a:avLst/>
@@ -21471,7 +21471,7 @@
                 </a:solidFill>
                 <a:latin typeface="Consolas"/>
               </a:rPr>
-              <a:t>&lt;Enemy type="skeleton" width="16" height="16" walkSpeed="20" health="1"&gt;</a:t>
+              <a:t>&lt;Enemy type="rat" width="16" height="16" walkSpeed="20" health="1"&gt;</a:t>
             </a:r>
           </a:p>
           <a:p>
@@ -21586,7 +21586,7 @@
                   <a:srgbClr val="DEE2E6"/>
                 </a:solidFill>
               </a:rPr>
-              <a:t>Someone writes type="skelton". When do you find out?</a:t>
+              <a:t>Someone writes type="rta". When do you find out?</a:t>
             </a:r>
           </a:p>
         </p:txBody>
@@ -26683,14 +26683,14 @@
       </p:sp>
       <p:pic>
         <p:nvPicPr>
-          <p:cNvPr id="82" name="Picture 85" descr="zelda_tilesheet.png"/>
+          <p:cNvPr id="82" name="Picture 85" descr="tilesheet.png"/>
           <p:cNvPicPr>
             <a:picLocks noChangeAspect="1"/>
           </p:cNvPicPr>
           <p:nvPr/>
         </p:nvPicPr>
         <p:blipFill>
-          <a:blip r:embed="rId7"/>
+          <a:blip r:embed="rId4"/>
           <a:stretch>
             <a:fillRect/>
           </a:stretch>
@@ -26698,7 +26698,7 @@
         <p:spPr>
           <a:xfrm>
             <a:off x="408714" y="1425731"/>
-            <a:ext cx="4573373" cy="3129150"/>
+            <a:ext cx="4573373" cy="3129149"/>
           </a:xfrm>
           <a:prstGeom prst="rect">
             <a:avLst/>
@@ -26714,7 +26714,7 @@
           <p:nvPr/>
         </p:nvPicPr>
         <p:blipFill>
-          <a:blip r:embed="rId6"/>
+          <a:blip r:embed="rId8"/>
           <a:stretch>
             <a:fillRect/>
           </a:stretch>
@@ -26738,15 +26738,15 @@
           <p:nvPr/>
         </p:nvPicPr>
         <p:blipFill>
-          <a:blip r:embed="rId5"/>
+          <a:blip r:embed="rId9"/>
           <a:stretch>
             <a:fillRect/>
           </a:stretch>
         </p:blipFill>
         <p:spPr>
           <a:xfrm>
-            <a:off x="5454471" y="874004"/>
-            <a:ext cx="848874" cy="1697748"/>
+            <a:off x="5454471" y="1086222"/>
+            <a:ext cx="848874" cy="1273311"/>
           </a:xfrm>
           <a:prstGeom prst="rect">
             <a:avLst/>
@@ -26755,14 +26755,14 @@
       </p:pic>
       <p:pic>
         <p:nvPicPr>
-          <p:cNvPr id="85" name="Picture 85" descr="zelda_entities.png"/>
+          <p:cNvPr id="85" name="Picture 85" descr="entities.png"/>
           <p:cNvPicPr>
             <a:picLocks noChangeAspect="1"/>
           </p:cNvPicPr>
           <p:nvPr/>
         </p:nvPicPr>
         <p:blipFill>
-          <a:blip r:embed="rId10"/>
+          <a:blip r:embed="rId3"/>
           <a:stretch>
             <a:fillRect/>
           </a:stretch>

</xml_diff>

<commit_message>
Decks: the screenshots that showed old art are retaken
Flappy Bird's title, Mario's levels, level maker and debug drawing, Zelda's room
and character sheets, and Pokemon's battle screen now show the games as they are.

Co-Authored-By: Claude Opus 5.5 <noreply@anthropic.com>
Claude-Session: https://claude.ai/code/session_012sjsUQBbC7zon57rWHoo9d
</commit_message>
<xml_diff>
--- a/slides/07 The Legend of Zelda.pptx
+++ b/slides/07 The Legend of Zelda.pptx
@@ -8059,14 +8059,14 @@
       </p:sp>
       <p:pic>
         <p:nvPicPr>
-          <p:cNvPr id="97" name="Picture 97" descr="topdown.png"/>
+          <p:cNvPr id="97" name="Picture 97" descr="f010.png"/>
           <p:cNvPicPr>
             <a:picLocks noChangeAspect="1"/>
           </p:cNvPicPr>
           <p:nvPr/>
         </p:nvPicPr>
         <p:blipFill>
-          <a:blip r:embed="rId3"/>
+          <a:blip r:embed="rId4"/>
           <a:stretch>
             <a:fillRect/>
           </a:stretch>
@@ -8074,7 +8074,7 @@
         <p:spPr>
           <a:xfrm>
             <a:off x="1138225" y="1062675"/>
-            <a:ext cx="6867553" cy="3862998"/>
+            <a:ext cx="6867552" cy="3862997"/>
           </a:xfrm>
           <a:prstGeom prst="rect">
             <a:avLst/>
@@ -26714,7 +26714,7 @@
           <p:nvPr/>
         </p:nvPicPr>
         <p:blipFill>
-          <a:blip r:embed="rId8"/>
+          <a:blip r:embed="rId6"/>
           <a:stretch>
             <a:fillRect/>
           </a:stretch>
@@ -26738,7 +26738,7 @@
           <p:nvPr/>
         </p:nvPicPr>
         <p:blipFill>
-          <a:blip r:embed="rId9"/>
+          <a:blip r:embed="rId7"/>
           <a:stretch>
             <a:fillRect/>
           </a:stretch>
@@ -26762,7 +26762,7 @@
           <p:nvPr/>
         </p:nvPicPr>
         <p:blipFill>
-          <a:blip r:embed="rId3"/>
+          <a:blip r:embed="rId5"/>
           <a:stretch>
             <a:fillRect/>
           </a:stretch>

</xml_diff>

<commit_message>
Zelda's recording and deck follow the enemies' new views; the Pokemon arrow points at the bar
Co-Authored-By: Claude Opus 5.5 <noreply@anthropic.com>
Claude-Session: https://claude.ai/code/session_012sjsUQBbC7zon57rWHoo9d
</commit_message>
<xml_diff>
--- a/slides/07 The Legend of Zelda.pptx
+++ b/slides/07 The Legend of Zelda.pptx
@@ -8059,22 +8059,22 @@
       </p:sp>
       <p:pic>
         <p:nvPicPr>
-          <p:cNvPr id="97" name="Picture 97" descr="f010.png"/>
+          <p:cNvPr id="97" name="Picture 97" descr="f026.png"/>
           <p:cNvPicPr>
             <a:picLocks noChangeAspect="1"/>
           </p:cNvPicPr>
           <p:nvPr/>
         </p:nvPicPr>
         <p:blipFill>
-          <a:blip r:embed="rId4"/>
+          <a:blip r:embed="rId3"/>
           <a:stretch>
             <a:fillRect/>
           </a:stretch>
         </p:blipFill>
         <p:spPr>
           <a:xfrm>
-            <a:off x="1138225" y="1062675"/>
-            <a:ext cx="6867552" cy="3862997"/>
+            <a:off x="1138226" y="1062675"/>
+            <a:ext cx="6867550" cy="3862996"/>
           </a:xfrm>
           <a:prstGeom prst="rect">
             <a:avLst/>
@@ -18209,15 +18209,15 @@
           <p:nvPr/>
         </p:nvPicPr>
         <p:blipFill>
-          <a:blip r:embed="rId3"/>
+          <a:blip r:embed="rId4"/>
           <a:stretch>
             <a:fillRect/>
           </a:stretch>
         </p:blipFill>
         <p:spPr>
           <a:xfrm>
-            <a:off x="1412778" y="1203675"/>
-            <a:ext cx="6318442" cy="3554123"/>
+            <a:off x="1412779" y="1203675"/>
+            <a:ext cx="6318440" cy="3554123"/>
           </a:xfrm>
           <a:prstGeom prst="rect">
             <a:avLst/>
@@ -26762,7 +26762,7 @@
           <p:nvPr/>
         </p:nvPicPr>
         <p:blipFill>
-          <a:blip r:embed="rId5"/>
+          <a:blip r:embed="rId3"/>
           <a:stretch>
             <a:fillRect/>
           </a:stretch>

</xml_diff>